<commit_message>
Redesign landing page to Deloitte-style consulting portal and generalize project branding
</commit_message>
<xml_diff>
--- a/docs/Reinsurance_Analytics_Training_Deck.pptx
+++ b/docs/Reinsurance_Analytics_Training_Deck.pptx
@@ -3188,7 +3188,7 @@
               </a:defRPr>
             </a:pPr>
             <a:r>
-              <a:t>Global Reinsurance Training &amp; Operational Playbook | AXA XL Portfolio Analytics</a:t>
+              <a:t>Global Reinsurance Training &amp; Operational Playbook | Enterprise Portfolio Governance</a:t>
             </a:r>
           </a:p>
         </p:txBody>
@@ -6407,7 +6407,7 @@
               </a:defRPr>
             </a:pPr>
             <a:r>
-              <a:t>Core Principles for Success in AXA XL Reinsurance Portfolio Analytics</a:t>
+              <a:t>Core Principles for Success in Reinsurance Portfolio Analytics</a:t>
             </a:r>
           </a:p>
         </p:txBody>
@@ -6776,7 +6776,7 @@
               </a:defRPr>
             </a:pPr>
             <a:r>
-              <a:t>• Team: AXA XL Reinsurance Portfolio Analytics (Gurgaon / Global)</a:t>
+              <a:t>• Team: Reinsurance Portfolio Analytics (Global Portfolio Management)</a:t>
             </a:r>
           </a:p>
           <a:p>

</xml_diff>